<commit_message>
Number financial appendix slides A1–A3
</commit_message>
<xml_diff>
--- a/synexo/Synapep_Financial_Slides.pptx
+++ b/synexo/Synapep_Financial_Slides.pptx
@@ -3720,7 +3720,7 @@
                 </a:solidFill>
                 <a:latin typeface="Calibri"/>
               </a:rPr>
-              <a:t>1</a:t>
+              <a:t>A1</a:t>
             </a:r>
           </a:p>
         </p:txBody>
@@ -4913,7 +4913,7 @@
                 </a:solidFill>
                 <a:latin typeface="Calibri"/>
               </a:rPr>
-              <a:t>2</a:t>
+              <a:t>A2</a:t>
             </a:r>
           </a:p>
         </p:txBody>
@@ -5976,7 +5976,7 @@
                 </a:solidFill>
                 <a:latin typeface="Calibri"/>
               </a:rPr>
-              <a:t>3</a:t>
+              <a:t>A3</a:t>
             </a:r>
           </a:p>
         </p:txBody>

</xml_diff>